<commit_message>
Added notes on my fifth meeting for my BA thesis
</commit_message>
<xml_diff>
--- a/dev_documents/meetings/meeting_05/meeting_05.pptx
+++ b/dev_documents/meetings/meeting_05/meeting_05.pptx
@@ -120,6 +120,11 @@
       </a:defRPr>
     </a:lvl9pPr>
   </p:defaultTextStyle>
+  <p:extLst>
+    <p:ext uri="{EFAFB233-063F-42B5-8137-9DF3F51BA10A}">
+      <p15:sldGuideLst xmlns:p15="http://schemas.microsoft.com/office/powerpoint/2012/main"/>
+    </p:ext>
+  </p:extLst>
 </p:presentation>
 </file>
 
@@ -272,7 +277,7 @@
           <a:p>
             <a:fld id="{16C949DD-DC1B-466F-B05B-AF5B6B3C0EAC}" type="datetimeFigureOut">
               <a:rPr lang="de-CH" smtClean="0"/>
-              <a:t>20.11.2025</a:t>
+              <a:t>21.11.2025</a:t>
             </a:fld>
             <a:endParaRPr lang="de-CH"/>
           </a:p>
@@ -472,7 +477,7 @@
           <a:p>
             <a:fld id="{16C949DD-DC1B-466F-B05B-AF5B6B3C0EAC}" type="datetimeFigureOut">
               <a:rPr lang="de-CH" smtClean="0"/>
-              <a:t>20.11.2025</a:t>
+              <a:t>21.11.2025</a:t>
             </a:fld>
             <a:endParaRPr lang="de-CH"/>
           </a:p>
@@ -682,7 +687,7 @@
           <a:p>
             <a:fld id="{16C949DD-DC1B-466F-B05B-AF5B6B3C0EAC}" type="datetimeFigureOut">
               <a:rPr lang="de-CH" smtClean="0"/>
-              <a:t>20.11.2025</a:t>
+              <a:t>21.11.2025</a:t>
             </a:fld>
             <a:endParaRPr lang="de-CH"/>
           </a:p>
@@ -882,7 +887,7 @@
           <a:p>
             <a:fld id="{16C949DD-DC1B-466F-B05B-AF5B6B3C0EAC}" type="datetimeFigureOut">
               <a:rPr lang="de-CH" smtClean="0"/>
-              <a:t>20.11.2025</a:t>
+              <a:t>21.11.2025</a:t>
             </a:fld>
             <a:endParaRPr lang="de-CH"/>
           </a:p>
@@ -1158,7 +1163,7 @@
           <a:p>
             <a:fld id="{16C949DD-DC1B-466F-B05B-AF5B6B3C0EAC}" type="datetimeFigureOut">
               <a:rPr lang="de-CH" smtClean="0"/>
-              <a:t>20.11.2025</a:t>
+              <a:t>21.11.2025</a:t>
             </a:fld>
             <a:endParaRPr lang="de-CH"/>
           </a:p>
@@ -1426,7 +1431,7 @@
           <a:p>
             <a:fld id="{16C949DD-DC1B-466F-B05B-AF5B6B3C0EAC}" type="datetimeFigureOut">
               <a:rPr lang="de-CH" smtClean="0"/>
-              <a:t>20.11.2025</a:t>
+              <a:t>21.11.2025</a:t>
             </a:fld>
             <a:endParaRPr lang="de-CH"/>
           </a:p>
@@ -1841,7 +1846,7 @@
           <a:p>
             <a:fld id="{16C949DD-DC1B-466F-B05B-AF5B6B3C0EAC}" type="datetimeFigureOut">
               <a:rPr lang="de-CH" smtClean="0"/>
-              <a:t>20.11.2025</a:t>
+              <a:t>21.11.2025</a:t>
             </a:fld>
             <a:endParaRPr lang="de-CH"/>
           </a:p>
@@ -1983,7 +1988,7 @@
           <a:p>
             <a:fld id="{16C949DD-DC1B-466F-B05B-AF5B6B3C0EAC}" type="datetimeFigureOut">
               <a:rPr lang="de-CH" smtClean="0"/>
-              <a:t>20.11.2025</a:t>
+              <a:t>21.11.2025</a:t>
             </a:fld>
             <a:endParaRPr lang="de-CH"/>
           </a:p>
@@ -2096,7 +2101,7 @@
           <a:p>
             <a:fld id="{16C949DD-DC1B-466F-B05B-AF5B6B3C0EAC}" type="datetimeFigureOut">
               <a:rPr lang="de-CH" smtClean="0"/>
-              <a:t>20.11.2025</a:t>
+              <a:t>21.11.2025</a:t>
             </a:fld>
             <a:endParaRPr lang="de-CH"/>
           </a:p>
@@ -2409,7 +2414,7 @@
           <a:p>
             <a:fld id="{16C949DD-DC1B-466F-B05B-AF5B6B3C0EAC}" type="datetimeFigureOut">
               <a:rPr lang="de-CH" smtClean="0"/>
-              <a:t>20.11.2025</a:t>
+              <a:t>21.11.2025</a:t>
             </a:fld>
             <a:endParaRPr lang="de-CH"/>
           </a:p>
@@ -2698,7 +2703,7 @@
           <a:p>
             <a:fld id="{16C949DD-DC1B-466F-B05B-AF5B6B3C0EAC}" type="datetimeFigureOut">
               <a:rPr lang="de-CH" smtClean="0"/>
-              <a:t>20.11.2025</a:t>
+              <a:t>21.11.2025</a:t>
             </a:fld>
             <a:endParaRPr lang="de-CH"/>
           </a:p>
@@ -2941,7 +2946,7 @@
           <a:p>
             <a:fld id="{16C949DD-DC1B-466F-B05B-AF5B6B3C0EAC}" type="datetimeFigureOut">
               <a:rPr lang="de-CH" smtClean="0"/>
-              <a:t>20.11.2025</a:t>
+              <a:t>21.11.2025</a:t>
             </a:fld>
             <a:endParaRPr lang="de-CH"/>
           </a:p>
@@ -3410,7 +3415,7 @@
           <a:p>
             <a:r>
               <a:rPr lang="de-DE" dirty="0"/>
-              <a:t>20.11.2025</a:t>
+              <a:t>21.11.2025</a:t>
             </a:r>
             <a:endParaRPr lang="de-CH" dirty="0"/>
           </a:p>

</xml_diff>

<commit_message>
Added powertpoint for meeting 06, pictures related to it, as well as notes on the meeting in designated folder
</commit_message>
<xml_diff>
--- a/dev_documents/meetings/meeting_05/meeting_05.pptx
+++ b/dev_documents/meetings/meeting_05/meeting_05.pptx
@@ -277,7 +277,7 @@
           <a:p>
             <a:fld id="{16C949DD-DC1B-466F-B05B-AF5B6B3C0EAC}" type="datetimeFigureOut">
               <a:rPr lang="de-CH" smtClean="0"/>
-              <a:t>21.11.2025</a:t>
+              <a:t>04.12.2025</a:t>
             </a:fld>
             <a:endParaRPr lang="de-CH"/>
           </a:p>
@@ -477,7 +477,7 @@
           <a:p>
             <a:fld id="{16C949DD-DC1B-466F-B05B-AF5B6B3C0EAC}" type="datetimeFigureOut">
               <a:rPr lang="de-CH" smtClean="0"/>
-              <a:t>21.11.2025</a:t>
+              <a:t>04.12.2025</a:t>
             </a:fld>
             <a:endParaRPr lang="de-CH"/>
           </a:p>
@@ -687,7 +687,7 @@
           <a:p>
             <a:fld id="{16C949DD-DC1B-466F-B05B-AF5B6B3C0EAC}" type="datetimeFigureOut">
               <a:rPr lang="de-CH" smtClean="0"/>
-              <a:t>21.11.2025</a:t>
+              <a:t>04.12.2025</a:t>
             </a:fld>
             <a:endParaRPr lang="de-CH"/>
           </a:p>
@@ -887,7 +887,7 @@
           <a:p>
             <a:fld id="{16C949DD-DC1B-466F-B05B-AF5B6B3C0EAC}" type="datetimeFigureOut">
               <a:rPr lang="de-CH" smtClean="0"/>
-              <a:t>21.11.2025</a:t>
+              <a:t>04.12.2025</a:t>
             </a:fld>
             <a:endParaRPr lang="de-CH"/>
           </a:p>
@@ -1163,7 +1163,7 @@
           <a:p>
             <a:fld id="{16C949DD-DC1B-466F-B05B-AF5B6B3C0EAC}" type="datetimeFigureOut">
               <a:rPr lang="de-CH" smtClean="0"/>
-              <a:t>21.11.2025</a:t>
+              <a:t>04.12.2025</a:t>
             </a:fld>
             <a:endParaRPr lang="de-CH"/>
           </a:p>
@@ -1431,7 +1431,7 @@
           <a:p>
             <a:fld id="{16C949DD-DC1B-466F-B05B-AF5B6B3C0EAC}" type="datetimeFigureOut">
               <a:rPr lang="de-CH" smtClean="0"/>
-              <a:t>21.11.2025</a:t>
+              <a:t>04.12.2025</a:t>
             </a:fld>
             <a:endParaRPr lang="de-CH"/>
           </a:p>
@@ -1846,7 +1846,7 @@
           <a:p>
             <a:fld id="{16C949DD-DC1B-466F-B05B-AF5B6B3C0EAC}" type="datetimeFigureOut">
               <a:rPr lang="de-CH" smtClean="0"/>
-              <a:t>21.11.2025</a:t>
+              <a:t>04.12.2025</a:t>
             </a:fld>
             <a:endParaRPr lang="de-CH"/>
           </a:p>
@@ -1988,7 +1988,7 @@
           <a:p>
             <a:fld id="{16C949DD-DC1B-466F-B05B-AF5B6B3C0EAC}" type="datetimeFigureOut">
               <a:rPr lang="de-CH" smtClean="0"/>
-              <a:t>21.11.2025</a:t>
+              <a:t>04.12.2025</a:t>
             </a:fld>
             <a:endParaRPr lang="de-CH"/>
           </a:p>
@@ -2101,7 +2101,7 @@
           <a:p>
             <a:fld id="{16C949DD-DC1B-466F-B05B-AF5B6B3C0EAC}" type="datetimeFigureOut">
               <a:rPr lang="de-CH" smtClean="0"/>
-              <a:t>21.11.2025</a:t>
+              <a:t>04.12.2025</a:t>
             </a:fld>
             <a:endParaRPr lang="de-CH"/>
           </a:p>
@@ -2414,7 +2414,7 @@
           <a:p>
             <a:fld id="{16C949DD-DC1B-466F-B05B-AF5B6B3C0EAC}" type="datetimeFigureOut">
               <a:rPr lang="de-CH" smtClean="0"/>
-              <a:t>21.11.2025</a:t>
+              <a:t>04.12.2025</a:t>
             </a:fld>
             <a:endParaRPr lang="de-CH"/>
           </a:p>
@@ -2703,7 +2703,7 @@
           <a:p>
             <a:fld id="{16C949DD-DC1B-466F-B05B-AF5B6B3C0EAC}" type="datetimeFigureOut">
               <a:rPr lang="de-CH" smtClean="0"/>
-              <a:t>21.11.2025</a:t>
+              <a:t>04.12.2025</a:t>
             </a:fld>
             <a:endParaRPr lang="de-CH"/>
           </a:p>
@@ -2946,7 +2946,7 @@
           <a:p>
             <a:fld id="{16C949DD-DC1B-466F-B05B-AF5B6B3C0EAC}" type="datetimeFigureOut">
               <a:rPr lang="de-CH" smtClean="0"/>
-              <a:t>21.11.2025</a:t>
+              <a:t>04.12.2025</a:t>
             </a:fld>
             <a:endParaRPr lang="de-CH"/>
           </a:p>
@@ -4765,31 +4765,6 @@
               <a:t>work</a:t>
             </a:r>
             <a:endParaRPr lang="de-CH" dirty="0"/>
-          </a:p>
-        </p:txBody>
-      </p:sp>
-      <p:sp>
-        <p:nvSpPr>
-          <p:cNvPr id="3" name="Inhaltsplatzhalter 2">
-            <a:extLst>
-              <a:ext uri="{FF2B5EF4-FFF2-40B4-BE49-F238E27FC236}">
-                <a16:creationId xmlns:a16="http://schemas.microsoft.com/office/drawing/2014/main" id="{601983F8-A675-6C17-A7B7-AD4F541E484D}"/>
-              </a:ext>
-            </a:extLst>
-          </p:cNvPr>
-          <p:cNvSpPr>
-            <a:spLocks noGrp="1"/>
-          </p:cNvSpPr>
-          <p:nvPr>
-            <p:ph idx="1"/>
-          </p:nvPr>
-        </p:nvSpPr>
-        <p:spPr/>
-        <p:txBody>
-          <a:bodyPr/>
-          <a:lstStyle/>
-          <a:p>
-            <a:endParaRPr lang="de-CH"/>
           </a:p>
         </p:txBody>
       </p:sp>

</xml_diff>